<commit_message>
Dashboard: Van- und Pkw-Variante je Quick Guide verlinkt
Quick-Guide-Karte, Tabellenspalte und Klickstrecken-Knoten bieten je
Guide die Links „Van“ und „Pkw“; CSV mit Spalte variante. Pkw-Guides
mit korrigierten Kennungen in FAQ und Glossar neu erzeugt.

Co-Authored-By: Claude Fable 5.1 <noreply@anthropic.com>
Claude-Session: https://claude.ai/code/session_01EhK4mVLcbJ5LMGgA3j15g8
</commit_message>
<xml_diff>
--- a/docs/quickguides/pkw/pptx/21_Quick_Guide_oneSCM_Spartenspezifische_Themen_Pkw.pptx
+++ b/docs/quickguides/pkw/pptx/21_Quick_Guide_oneSCM_Spartenspezifische_Themen_Pkw.pptx
@@ -3338,18 +3338,18 @@
                 <a:ea typeface="MB Corpo S Text Office" pitchFamily="34" charset="-122"/>
                 <a:cs typeface="MB Corpo S Text Office" pitchFamily="34" charset="-120"/>
               </a:rPr>
-              <a:t>Kann ich mit der Van-Rolle Pkw-Verträge anlegen?</a:t>
-            </a:r>
-            <a:r>
-              <a:rPr lang="en-US" sz="900" dirty="0">
-                <a:solidFill>
-                  <a:srgbClr val="262626"/>
-                </a:solidFill>
-                <a:latin typeface="MB Corpo S Text Office" pitchFamily="34" charset="0"/>
-                <a:ea typeface="MB Corpo S Text Office" pitchFamily="34" charset="-122"/>
-                <a:cs typeface="MB Corpo S Text Office" pitchFamily="34" charset="-120"/>
-              </a:rPr>
-              <a:t> Nein, dafür ist die Pkw-Rolle und der passende Kontext nötig (Kapitel 2.2).</a:t>
+              <a:t>Kann ich mit der Pkw-Rolle Van-Verträge anlegen?</a:t>
+            </a:r>
+            <a:r>
+              <a:rPr lang="en-US" sz="900" dirty="0">
+                <a:solidFill>
+                  <a:srgbClr val="262626"/>
+                </a:solidFill>
+                <a:latin typeface="MB Corpo S Text Office" pitchFamily="34" charset="0"/>
+                <a:ea typeface="MB Corpo S Text Office" pitchFamily="34" charset="-122"/>
+                <a:cs typeface="MB Corpo S Text Office" pitchFamily="34" charset="-120"/>
+              </a:rPr>
+              <a:t> Nein, dafür ist die Van-Rolle und der passende Kontext nötig (Kapitel 2.2).</a:t>
             </a:r>
             <a:endParaRPr lang="en-US" sz="900" dirty="0"/>
           </a:p>

</xml_diff>